<commit_message>
Stage 8 review fixes: B-032
</commit_message>
<xml_diff>
--- a/output/archive/Archive/Users/mellerscombe_old_laptop/Presentations/Working/Copy of Screening_workflow.pptx
+++ b/output/archive/Archive/Users/mellerscombe_old_laptop/Presentations/Working/Copy of Screening_workflow.pptx
@@ -3929,7 +3929,7 @@
               <a:rPr sz="2000">
                 <a:latin typeface="Times New Roman"/>
               </a:rPr>
-              <a:t>Plate acceptance before any compound read</a:t>
+              <a:t>Screening set run with controls; plate acceptance before compound interpretation</a:t>
             </a:r>
           </a:p>
           <a:p>
@@ -4473,7 +4473,7 @@
               <a:rPr sz="1800">
                 <a:latin typeface="Times New Roman"/>
               </a:rPr>
-              <a:t>Accepted plates go into the screening set</a:t>
+              <a:t>Results from accepted plates go into the screening set review</a:t>
             </a:r>
           </a:p>
           <a:p>
@@ -5207,7 +5207,7 @@
                         <a:rPr sz="1400">
                           <a:latin typeface="Times New Roman"/>
                         </a:rPr>
-                        <a:t>Screening set review</a:t>
+                        <a:t>Acceptance record review</a:t>
                       </a:r>
                     </a:p>
                   </a:txBody>

</xml_diff>